<commit_message>
feat: enhance Week 1, Session 4 PowerPoint content by adding confusion matrix metrics and precision-recall-F1 explanations for improved educational clarity
</commit_message>
<xml_diff>
--- a/web-presentation/pdf-exports/Week1-Session4-Naive-Bayes-Trees-Evaluation.pptx
+++ b/web-presentation/pdf-exports/Week1-Session4-Naive-Bayes-Trees-Evaluation.pptx
@@ -21,6 +21,8 @@
     <p:sldId id="269" r:id="rId20"/>
     <p:sldId id="270" r:id="rId21"/>
     <p:sldId id="271" r:id="rId22"/>
+    <p:sldId id="272" r:id="rId23"/>
+    <p:sldId id="273" r:id="rId24"/>
   </p:sldIdLst>
   <p:sldSz cx="12191695" cy="6858000" type="screen4x3"/>
   <p:notesSz cx="6858000" cy="9144000"/>
@@ -4227,7 +4229,7 @@
                 <a:ea typeface="DIN Next LT W23"/>
                 <a:cs typeface="DIN Next LT W23"/>
               </a:rPr>
-              <a:t>10  /  16</a:t>
+              <a:t>10  /  18</a:t>
             </a:r>
           </a:p>
         </p:txBody>
@@ -4988,7 +4990,7 @@
                 <a:ea typeface="DIN Next LT W23"/>
                 <a:cs typeface="DIN Next LT W23"/>
               </a:rPr>
-              <a:t>11  /  16</a:t>
+              <a:t>11  /  18</a:t>
             </a:r>
           </a:p>
         </p:txBody>
@@ -5499,7 +5501,7 @@
                 <a:ea typeface="DIN Next LT W23"/>
                 <a:cs typeface="DIN Next LT W23"/>
               </a:rPr>
-              <a:t>12  /  16</a:t>
+              <a:t>12  /  18</a:t>
             </a:r>
           </a:p>
         </p:txBody>
@@ -6348,7 +6350,7 @@
                 <a:ea typeface="DIN Next LT W23"/>
                 <a:cs typeface="DIN Next LT W23"/>
               </a:rPr>
-              <a:t>13  /  16</a:t>
+              <a:t>13  /  18</a:t>
             </a:r>
           </a:p>
         </p:txBody>
@@ -7180,7 +7182,7 @@
                 <a:ea typeface="DIN Next LT W23"/>
                 <a:cs typeface="DIN Next LT W23"/>
               </a:rPr>
-              <a:t>14  /  16</a:t>
+              <a:t>14  /  18</a:t>
             </a:r>
           </a:p>
         </p:txBody>
@@ -7959,7 +7961,7 @@
                 <a:ea typeface="DIN Next LT W23"/>
                 <a:cs typeface="DIN Next LT W23"/>
               </a:rPr>
-              <a:t>15  /  16</a:t>
+              <a:t>15  /  18</a:t>
             </a:r>
           </a:p>
         </p:txBody>
@@ -8808,7 +8810,1234 @@
                 <a:ea typeface="DIN Next LT W23"/>
                 <a:cs typeface="DIN Next LT W23"/>
               </a:rPr>
-              <a:t>16  /  16</a:t>
+              <a:t>16  /  18</a:t>
+            </a:r>
+          </a:p>
+        </p:txBody>
+      </p:sp>
+    </p:spTree>
+  </p:cSld>
+  <p:clrMapOvr>
+    <a:masterClrMapping/>
+  </p:clrMapOvr>
+</p:sld>
+</file>
+
+<file path=ppt/slides/slide17.xml><?xml version="1.0" encoding="utf-8"?>
+<p:sld xmlns:a="http://schemas.openxmlformats.org/drawingml/2006/main" xmlns:p="http://schemas.openxmlformats.org/presentationml/2006/main" xmlns:r="http://schemas.openxmlformats.org/officeDocument/2006/relationships">
+  <p:cSld>
+    <p:bg>
+      <p:bgPr>
+        <a:solidFill>
+          <a:srgbClr val="FAF8FF"/>
+        </a:solidFill>
+        <a:effectLst/>
+      </p:bgPr>
+    </p:bg>
+    <p:spTree>
+      <p:nvGrpSpPr>
+        <p:cNvPr id="1" name=""/>
+        <p:cNvGrpSpPr/>
+        <p:nvPr/>
+      </p:nvGrpSpPr>
+      <p:grpSpPr/>
+      <p:sp>
+        <p:nvSpPr>
+          <p:cNvPr id="2" name="Rectangle 1"/>
+          <p:cNvSpPr/>
+          <p:nvPr/>
+        </p:nvSpPr>
+        <p:spPr>
+          <a:xfrm>
+            <a:off x="12136831" y="0"/>
+            <a:ext cx="54864" cy="6858000"/>
+          </a:xfrm>
+          <a:prstGeom prst="rect">
+            <a:avLst/>
+          </a:prstGeom>
+          <a:solidFill>
+            <a:srgbClr val="5234B7"/>
+          </a:solidFill>
+          <a:ln>
+            <a:noFill/>
+          </a:ln>
+          <a:effectLst/>
+        </p:spPr>
+        <p:style>
+          <a:lnRef idx="1">
+            <a:schemeClr val="accent1"/>
+          </a:lnRef>
+          <a:fillRef idx="3">
+            <a:schemeClr val="accent1"/>
+          </a:fillRef>
+          <a:effectRef idx="2">
+            <a:schemeClr val="accent1"/>
+          </a:effectRef>
+          <a:fontRef idx="minor">
+            <a:schemeClr val="lt1"/>
+          </a:fontRef>
+        </p:style>
+        <p:txBody>
+          <a:bodyPr rtlCol="0" anchor="ctr"/>
+          <a:lstStyle/>
+          <a:p>
+            <a:pPr algn="ctr"/>
+          </a:p>
+        </p:txBody>
+      </p:sp>
+      <p:pic>
+        <p:nvPicPr>
+          <p:cNvPr id="3" name="Picture 2" descr="etra-wordmark.png"/>
+          <p:cNvPicPr>
+            <a:picLocks noChangeAspect="1"/>
+          </p:cNvPicPr>
+          <p:nvPr/>
+        </p:nvPicPr>
+        <p:blipFill>
+          <a:blip r:embed="rId2"/>
+          <a:stretch>
+            <a:fillRect/>
+          </a:stretch>
+        </p:blipFill>
+        <p:spPr>
+          <a:xfrm>
+            <a:off x="10561320" y="411480"/>
+            <a:ext cx="1206201" cy="320040"/>
+          </a:xfrm>
+          <a:prstGeom prst="rect">
+            <a:avLst/>
+          </a:prstGeom>
+        </p:spPr>
+      </p:pic>
+      <p:sp>
+        <p:nvSpPr>
+          <p:cNvPr id="4" name="TextBox 3"/>
+          <p:cNvSpPr txBox="1"/>
+          <p:nvPr/>
+        </p:nvSpPr>
+        <p:spPr>
+          <a:xfrm>
+            <a:off x="548640" y="438912"/>
+            <a:ext cx="7772400" cy="274320"/>
+          </a:xfrm>
+          <a:prstGeom prst="rect">
+            <a:avLst/>
+          </a:prstGeom>
+          <a:noFill/>
+        </p:spPr>
+        <p:txBody>
+          <a:bodyPr wrap="square" anchor="t">
+            <a:spAutoFit/>
+          </a:bodyPr>
+          <a:lstStyle/>
+          <a:p>
+            <a:pPr algn="l"/>
+            <a:r>
+              <a:rPr sz="1200" b="0">
+                <a:solidFill>
+                  <a:srgbClr val="5A5470"/>
+                </a:solidFill>
+                <a:latin typeface="DIN Next LT W23"/>
+                <a:ea typeface="DIN Next LT W23"/>
+                <a:cs typeface="DIN Next LT W23"/>
+              </a:rPr>
+              <a:t>S04  ·  Classical ML</a:t>
+            </a:r>
+          </a:p>
+        </p:txBody>
+      </p:sp>
+      <p:sp>
+        <p:nvSpPr>
+          <p:cNvPr id="5" name="Rectangle 4"/>
+          <p:cNvSpPr/>
+          <p:nvPr/>
+        </p:nvSpPr>
+        <p:spPr>
+          <a:xfrm>
+            <a:off x="548640" y="822960"/>
+            <a:ext cx="11064240" cy="10972"/>
+          </a:xfrm>
+          <a:prstGeom prst="rect">
+            <a:avLst/>
+          </a:prstGeom>
+          <a:solidFill>
+            <a:srgbClr val="E4DCF4"/>
+          </a:solidFill>
+          <a:ln>
+            <a:noFill/>
+          </a:ln>
+          <a:effectLst/>
+        </p:spPr>
+        <p:style>
+          <a:lnRef idx="1">
+            <a:schemeClr val="accent1"/>
+          </a:lnRef>
+          <a:fillRef idx="3">
+            <a:schemeClr val="accent1"/>
+          </a:fillRef>
+          <a:effectRef idx="2">
+            <a:schemeClr val="accent1"/>
+          </a:effectRef>
+          <a:fontRef idx="minor">
+            <a:schemeClr val="lt1"/>
+          </a:fontRef>
+        </p:style>
+        <p:txBody>
+          <a:bodyPr rtlCol="0" anchor="ctr"/>
+          <a:lstStyle/>
+          <a:p>
+            <a:pPr algn="ctr"/>
+          </a:p>
+        </p:txBody>
+      </p:sp>
+      <p:sp>
+        <p:nvSpPr>
+          <p:cNvPr id="6" name="TextBox 5"/>
+          <p:cNvSpPr txBox="1"/>
+          <p:nvPr/>
+        </p:nvSpPr>
+        <p:spPr>
+          <a:xfrm>
+            <a:off x="548640" y="1051560"/>
+            <a:ext cx="10241280" cy="594360"/>
+          </a:xfrm>
+          <a:prstGeom prst="rect">
+            <a:avLst/>
+          </a:prstGeom>
+          <a:noFill/>
+        </p:spPr>
+        <p:txBody>
+          <a:bodyPr wrap="square" anchor="t">
+            <a:spAutoFit/>
+          </a:bodyPr>
+          <a:lstStyle/>
+          <a:p>
+            <a:pPr algn="l"/>
+            <a:r>
+              <a:rPr sz="3200" b="1">
+                <a:solidFill>
+                  <a:srgbClr val="5234B7"/>
+                </a:solidFill>
+                <a:latin typeface="DIN Next LT W23"/>
+                <a:ea typeface="DIN Next LT W23"/>
+                <a:cs typeface="DIN Next LT W23"/>
+              </a:rPr>
+              <a:t>Confusion Matrix Cells</a:t>
+            </a:r>
+          </a:p>
+        </p:txBody>
+      </p:sp>
+      <p:sp>
+        <p:nvSpPr>
+          <p:cNvPr id="7" name="TextBox 6"/>
+          <p:cNvSpPr txBox="1"/>
+          <p:nvPr/>
+        </p:nvSpPr>
+        <p:spPr>
+          <a:xfrm>
+            <a:off x="548640" y="1600200"/>
+            <a:ext cx="10241280" cy="365760"/>
+          </a:xfrm>
+          <a:prstGeom prst="rect">
+            <a:avLst/>
+          </a:prstGeom>
+          <a:noFill/>
+        </p:spPr>
+        <p:txBody>
+          <a:bodyPr wrap="square" anchor="t">
+            <a:spAutoFit/>
+          </a:bodyPr>
+          <a:lstStyle/>
+          <a:p>
+            <a:pPr algn="l"/>
+            <a:r>
+              <a:rPr sz="1500" b="0">
+                <a:solidFill>
+                  <a:srgbClr val="5A5470"/>
+                </a:solidFill>
+                <a:latin typeface="DIN Next LT W23"/>
+                <a:ea typeface="DIN Next LT W23"/>
+                <a:cs typeface="DIN Next LT W23"/>
+              </a:rPr>
+              <a:t>Metric Meanings</a:t>
+            </a:r>
+          </a:p>
+        </p:txBody>
+      </p:sp>
+      <p:graphicFrame>
+        <p:nvGraphicFramePr>
+          <p:cNvPr id="8" name="Table 7"/>
+          <p:cNvGraphicFramePr>
+            <a:graphicFrameLocks noGrp="1"/>
+          </p:cNvGraphicFramePr>
+          <p:nvPr/>
+        </p:nvGraphicFramePr>
+        <p:xfrm>
+          <a:off x="548640" y="2057400"/>
+          <a:ext cx="10972800" cy="2377440"/>
+        </p:xfrm>
+        <a:graphic>
+          <a:graphicData uri="http://schemas.openxmlformats.org/drawingml/2006/table">
+            <a:tbl>
+              <a:tblPr firstRow="1" bandRow="1">
+                <a:tableStyleId>{5C22544A-7EE6-4342-B048-85BDC9FD1C3A}</a:tableStyleId>
+              </a:tblPr>
+              <a:tblGrid>
+                <a:gridCol w="5486400"/>
+                <a:gridCol w="5486400"/>
+              </a:tblGrid>
+              <a:tr h="475488">
+                <a:tc>
+                  <a:txBody>
+                    <a:bodyPr/>
+                    <a:lstStyle/>
+                    <a:p>
+                      <a:pPr algn="ctr"/>
+                      <a:r>
+                        <a:rPr sz="1200" b="1">
+                          <a:solidFill>
+                            <a:srgbClr val="FFFFFF"/>
+                          </a:solidFill>
+                          <a:latin typeface="Helvetica"/>
+                        </a:rPr>
+                        <a:t>Metric</a:t>
+                      </a:r>
+                    </a:p>
+                  </a:txBody>
+                  <a:tcPr>
+                    <a:solidFill>
+                      <a:srgbClr val="5234B7"/>
+                    </a:solidFill>
+                  </a:tcPr>
+                </a:tc>
+                <a:tc>
+                  <a:txBody>
+                    <a:bodyPr/>
+                    <a:lstStyle/>
+                    <a:p>
+                      <a:pPr algn="ctr"/>
+                      <a:r>
+                        <a:rPr sz="1200" b="1">
+                          <a:solidFill>
+                            <a:srgbClr val="FFFFFF"/>
+                          </a:solidFill>
+                          <a:latin typeface="Helvetica"/>
+                        </a:rPr>
+                        <a:t>Meaning</a:t>
+                      </a:r>
+                    </a:p>
+                  </a:txBody>
+                  <a:tcPr>
+                    <a:solidFill>
+                      <a:srgbClr val="5234B7"/>
+                    </a:solidFill>
+                  </a:tcPr>
+                </a:tc>
+              </a:tr>
+              <a:tr h="475488">
+                <a:tc>
+                  <a:txBody>
+                    <a:bodyPr/>
+                    <a:lstStyle/>
+                    <a:p>
+                      <a:pPr algn="l"/>
+                      <a:r>
+                        <a:rPr sz="1300" b="1">
+                          <a:solidFill>
+                            <a:srgbClr val="5234B7"/>
+                          </a:solidFill>
+                          <a:latin typeface="Helvetica"/>
+                        </a:rPr>
+                        <a:t>TP</a:t>
+                      </a:r>
+                    </a:p>
+                  </a:txBody>
+                  <a:tcPr>
+                    <a:solidFill>
+                      <a:srgbClr val="EEE8FA"/>
+                    </a:solidFill>
+                  </a:tcPr>
+                </a:tc>
+                <a:tc>
+                  <a:txBody>
+                    <a:bodyPr/>
+                    <a:lstStyle/>
+                    <a:p>
+                      <a:pPr algn="l"/>
+                      <a:r>
+                        <a:rPr sz="1300" b="0">
+                          <a:solidFill>
+                            <a:srgbClr val="121018"/>
+                          </a:solidFill>
+                          <a:latin typeface="Helvetica"/>
+                        </a:rPr>
+                        <a:t>Correctly predicted positives</a:t>
+                      </a:r>
+                    </a:p>
+                  </a:txBody>
+                  <a:tcPr>
+                    <a:solidFill>
+                      <a:srgbClr val="EEE8FA"/>
+                    </a:solidFill>
+                  </a:tcPr>
+                </a:tc>
+              </a:tr>
+              <a:tr h="475488">
+                <a:tc>
+                  <a:txBody>
+                    <a:bodyPr/>
+                    <a:lstStyle/>
+                    <a:p>
+                      <a:pPr algn="l"/>
+                      <a:r>
+                        <a:rPr sz="1300" b="1">
+                          <a:solidFill>
+                            <a:srgbClr val="5234B7"/>
+                          </a:solidFill>
+                          <a:latin typeface="Helvetica"/>
+                        </a:rPr>
+                        <a:t>TN</a:t>
+                      </a:r>
+                    </a:p>
+                  </a:txBody>
+                  <a:tcPr>
+                    <a:solidFill>
+                      <a:srgbClr val="F5F1FC"/>
+                    </a:solidFill>
+                  </a:tcPr>
+                </a:tc>
+                <a:tc>
+                  <a:txBody>
+                    <a:bodyPr/>
+                    <a:lstStyle/>
+                    <a:p>
+                      <a:pPr algn="l"/>
+                      <a:r>
+                        <a:rPr sz="1300" b="0">
+                          <a:solidFill>
+                            <a:srgbClr val="121018"/>
+                          </a:solidFill>
+                          <a:latin typeface="Helvetica"/>
+                        </a:rPr>
+                        <a:t>Correctly predicted negatives</a:t>
+                      </a:r>
+                    </a:p>
+                  </a:txBody>
+                  <a:tcPr>
+                    <a:solidFill>
+                      <a:srgbClr val="F5F1FC"/>
+                    </a:solidFill>
+                  </a:tcPr>
+                </a:tc>
+              </a:tr>
+              <a:tr h="475488">
+                <a:tc>
+                  <a:txBody>
+                    <a:bodyPr/>
+                    <a:lstStyle/>
+                    <a:p>
+                      <a:pPr algn="l"/>
+                      <a:r>
+                        <a:rPr sz="1300" b="1">
+                          <a:solidFill>
+                            <a:srgbClr val="5234B7"/>
+                          </a:solidFill>
+                          <a:latin typeface="Helvetica"/>
+                        </a:rPr>
+                        <a:t>FP</a:t>
+                      </a:r>
+                    </a:p>
+                  </a:txBody>
+                  <a:tcPr>
+                    <a:solidFill>
+                      <a:srgbClr val="EEE8FA"/>
+                    </a:solidFill>
+                  </a:tcPr>
+                </a:tc>
+                <a:tc>
+                  <a:txBody>
+                    <a:bodyPr/>
+                    <a:lstStyle/>
+                    <a:p>
+                      <a:pPr algn="l"/>
+                      <a:r>
+                        <a:rPr sz="1300" b="0">
+                          <a:solidFill>
+                            <a:srgbClr val="121018"/>
+                          </a:solidFill>
+                          <a:latin typeface="Helvetica"/>
+                        </a:rPr>
+                        <a:t>Incorrectly predicted positives</a:t>
+                      </a:r>
+                    </a:p>
+                  </a:txBody>
+                  <a:tcPr>
+                    <a:solidFill>
+                      <a:srgbClr val="EEE8FA"/>
+                    </a:solidFill>
+                  </a:tcPr>
+                </a:tc>
+              </a:tr>
+              <a:tr h="475488">
+                <a:tc>
+                  <a:txBody>
+                    <a:bodyPr/>
+                    <a:lstStyle/>
+                    <a:p>
+                      <a:pPr algn="l"/>
+                      <a:r>
+                        <a:rPr sz="1300" b="1">
+                          <a:solidFill>
+                            <a:srgbClr val="5234B7"/>
+                          </a:solidFill>
+                          <a:latin typeface="Helvetica"/>
+                        </a:rPr>
+                        <a:t>FN</a:t>
+                      </a:r>
+                    </a:p>
+                  </a:txBody>
+                  <a:tcPr>
+                    <a:solidFill>
+                      <a:srgbClr val="F5F1FC"/>
+                    </a:solidFill>
+                  </a:tcPr>
+                </a:tc>
+                <a:tc>
+                  <a:txBody>
+                    <a:bodyPr/>
+                    <a:lstStyle/>
+                    <a:p>
+                      <a:pPr algn="l"/>
+                      <a:r>
+                        <a:rPr sz="1300" b="0">
+                          <a:solidFill>
+                            <a:srgbClr val="121018"/>
+                          </a:solidFill>
+                          <a:latin typeface="Helvetica"/>
+                        </a:rPr>
+                        <a:t>Incorrectly predicted negatives</a:t>
+                      </a:r>
+                    </a:p>
+                  </a:txBody>
+                  <a:tcPr>
+                    <a:solidFill>
+                      <a:srgbClr val="F5F1FC"/>
+                    </a:solidFill>
+                  </a:tcPr>
+                </a:tc>
+              </a:tr>
+            </a:tbl>
+          </a:graphicData>
+        </a:graphic>
+      </p:graphicFrame>
+      <p:sp>
+        <p:nvSpPr>
+          <p:cNvPr id="9" name="Rounded Rectangle 8"/>
+          <p:cNvSpPr/>
+          <p:nvPr/>
+        </p:nvSpPr>
+        <p:spPr>
+          <a:xfrm>
+            <a:off x="548640" y="4507992"/>
+            <a:ext cx="10972800" cy="411480"/>
+          </a:xfrm>
+          <a:prstGeom prst="roundRect">
+            <a:avLst>
+              <a:gd name="adj" fmla="val 10000"/>
+            </a:avLst>
+          </a:prstGeom>
+          <a:solidFill>
+            <a:srgbClr val="EEE8FA"/>
+          </a:solidFill>
+          <a:ln>
+            <a:noFill/>
+          </a:ln>
+          <a:effectLst/>
+        </p:spPr>
+        <p:style>
+          <a:lnRef idx="1">
+            <a:schemeClr val="accent1"/>
+          </a:lnRef>
+          <a:fillRef idx="3">
+            <a:schemeClr val="accent1"/>
+          </a:fillRef>
+          <a:effectRef idx="2">
+            <a:schemeClr val="accent1"/>
+          </a:effectRef>
+          <a:fontRef idx="minor">
+            <a:schemeClr val="lt1"/>
+          </a:fontRef>
+        </p:style>
+        <p:txBody>
+          <a:bodyPr rtlCol="0" anchor="ctr"/>
+          <a:lstStyle/>
+          <a:p>
+            <a:pPr algn="ctr"/>
+          </a:p>
+        </p:txBody>
+      </p:sp>
+      <p:sp>
+        <p:nvSpPr>
+          <p:cNvPr id="10" name="TextBox 9"/>
+          <p:cNvSpPr txBox="1"/>
+          <p:nvPr/>
+        </p:nvSpPr>
+        <p:spPr>
+          <a:xfrm>
+            <a:off x="868680" y="4581144"/>
+            <a:ext cx="10332720" cy="292608"/>
+          </a:xfrm>
+          <a:prstGeom prst="rect">
+            <a:avLst/>
+          </a:prstGeom>
+          <a:noFill/>
+        </p:spPr>
+        <p:txBody>
+          <a:bodyPr wrap="square" anchor="t">
+            <a:spAutoFit/>
+          </a:bodyPr>
+          <a:lstStyle/>
+          <a:p>
+            <a:pPr algn="l"/>
+            <a:r>
+              <a:rPr sz="1200" b="0">
+                <a:solidFill>
+                  <a:srgbClr val="5A5470"/>
+                </a:solidFill>
+                <a:latin typeface="DIN Next LT W23"/>
+                <a:ea typeface="DIN Next LT W23"/>
+                <a:cs typeface="DIN Next LT W23"/>
+              </a:rPr>
+              <a:t>These four counts are the building blocks of precision, recall, and F1.</a:t>
+            </a:r>
+          </a:p>
+        </p:txBody>
+      </p:sp>
+      <p:sp>
+        <p:nvSpPr>
+          <p:cNvPr id="11" name="Rectangle 10"/>
+          <p:cNvSpPr/>
+          <p:nvPr/>
+        </p:nvSpPr>
+        <p:spPr>
+          <a:xfrm>
+            <a:off x="548640" y="6446520"/>
+            <a:ext cx="11064240" cy="10972"/>
+          </a:xfrm>
+          <a:prstGeom prst="rect">
+            <a:avLst/>
+          </a:prstGeom>
+          <a:solidFill>
+            <a:srgbClr val="5234B7"/>
+          </a:solidFill>
+          <a:ln>
+            <a:noFill/>
+          </a:ln>
+          <a:effectLst/>
+        </p:spPr>
+        <p:style>
+          <a:lnRef idx="1">
+            <a:schemeClr val="accent1"/>
+          </a:lnRef>
+          <a:fillRef idx="3">
+            <a:schemeClr val="accent1"/>
+          </a:fillRef>
+          <a:effectRef idx="2">
+            <a:schemeClr val="accent1"/>
+          </a:effectRef>
+          <a:fontRef idx="minor">
+            <a:schemeClr val="lt1"/>
+          </a:fontRef>
+        </p:style>
+        <p:txBody>
+          <a:bodyPr rtlCol="0" anchor="ctr"/>
+          <a:lstStyle/>
+          <a:p>
+            <a:pPr algn="ctr"/>
+          </a:p>
+        </p:txBody>
+      </p:sp>
+      <p:sp>
+        <p:nvSpPr>
+          <p:cNvPr id="12" name="TextBox 11"/>
+          <p:cNvSpPr txBox="1"/>
+          <p:nvPr/>
+        </p:nvSpPr>
+        <p:spPr>
+          <a:xfrm>
+            <a:off x="548640" y="6510528"/>
+            <a:ext cx="2743200" cy="256032"/>
+          </a:xfrm>
+          <a:prstGeom prst="rect">
+            <a:avLst/>
+          </a:prstGeom>
+          <a:noFill/>
+        </p:spPr>
+        <p:txBody>
+          <a:bodyPr wrap="square" anchor="t">
+            <a:spAutoFit/>
+          </a:bodyPr>
+          <a:lstStyle/>
+          <a:p>
+            <a:pPr algn="l"/>
+            <a:r>
+              <a:rPr sz="1100" b="1">
+                <a:solidFill>
+                  <a:srgbClr val="5234B7"/>
+                </a:solidFill>
+                <a:latin typeface="DIN Next LT W23"/>
+                <a:ea typeface="DIN Next LT W23"/>
+                <a:cs typeface="DIN Next LT W23"/>
+              </a:rPr>
+              <a:t>ETRA</a:t>
+            </a:r>
+          </a:p>
+        </p:txBody>
+      </p:sp>
+      <p:sp>
+        <p:nvSpPr>
+          <p:cNvPr id="13" name="TextBox 12"/>
+          <p:cNvSpPr txBox="1"/>
+          <p:nvPr/>
+        </p:nvSpPr>
+        <p:spPr>
+          <a:xfrm>
+            <a:off x="9601200" y="6510528"/>
+            <a:ext cx="2011680" cy="256032"/>
+          </a:xfrm>
+          <a:prstGeom prst="rect">
+            <a:avLst/>
+          </a:prstGeom>
+          <a:noFill/>
+        </p:spPr>
+        <p:txBody>
+          <a:bodyPr wrap="square" anchor="t">
+            <a:spAutoFit/>
+          </a:bodyPr>
+          <a:lstStyle/>
+          <a:p>
+            <a:pPr algn="r"/>
+            <a:r>
+              <a:rPr sz="1100" b="0">
+                <a:solidFill>
+                  <a:srgbClr val="5A5470"/>
+                </a:solidFill>
+                <a:latin typeface="DIN Next LT W23"/>
+                <a:ea typeface="DIN Next LT W23"/>
+                <a:cs typeface="DIN Next LT W23"/>
+              </a:rPr>
+              <a:t>17  /  18</a:t>
+            </a:r>
+          </a:p>
+        </p:txBody>
+      </p:sp>
+    </p:spTree>
+  </p:cSld>
+  <p:clrMapOvr>
+    <a:masterClrMapping/>
+  </p:clrMapOvr>
+</p:sld>
+</file>
+
+<file path=ppt/slides/slide18.xml><?xml version="1.0" encoding="utf-8"?>
+<p:sld xmlns:a="http://schemas.openxmlformats.org/drawingml/2006/main" xmlns:p="http://schemas.openxmlformats.org/presentationml/2006/main" xmlns:r="http://schemas.openxmlformats.org/officeDocument/2006/relationships">
+  <p:cSld>
+    <p:bg>
+      <p:bgPr>
+        <a:solidFill>
+          <a:srgbClr val="FAF8FF"/>
+        </a:solidFill>
+        <a:effectLst/>
+      </p:bgPr>
+    </p:bg>
+    <p:spTree>
+      <p:nvGrpSpPr>
+        <p:cNvPr id="1" name=""/>
+        <p:cNvGrpSpPr/>
+        <p:nvPr/>
+      </p:nvGrpSpPr>
+      <p:grpSpPr/>
+      <p:sp>
+        <p:nvSpPr>
+          <p:cNvPr id="2" name="Rectangle 1"/>
+          <p:cNvSpPr/>
+          <p:nvPr/>
+        </p:nvSpPr>
+        <p:spPr>
+          <a:xfrm>
+            <a:off x="12136831" y="0"/>
+            <a:ext cx="54864" cy="6858000"/>
+          </a:xfrm>
+          <a:prstGeom prst="rect">
+            <a:avLst/>
+          </a:prstGeom>
+          <a:solidFill>
+            <a:srgbClr val="5234B7"/>
+          </a:solidFill>
+          <a:ln>
+            <a:noFill/>
+          </a:ln>
+          <a:effectLst/>
+        </p:spPr>
+        <p:style>
+          <a:lnRef idx="1">
+            <a:schemeClr val="accent1"/>
+          </a:lnRef>
+          <a:fillRef idx="3">
+            <a:schemeClr val="accent1"/>
+          </a:fillRef>
+          <a:effectRef idx="2">
+            <a:schemeClr val="accent1"/>
+          </a:effectRef>
+          <a:fontRef idx="minor">
+            <a:schemeClr val="lt1"/>
+          </a:fontRef>
+        </p:style>
+        <p:txBody>
+          <a:bodyPr rtlCol="0" anchor="ctr"/>
+          <a:lstStyle/>
+          <a:p>
+            <a:pPr algn="ctr"/>
+          </a:p>
+        </p:txBody>
+      </p:sp>
+      <p:pic>
+        <p:nvPicPr>
+          <p:cNvPr id="3" name="Picture 2" descr="etra-wordmark.png"/>
+          <p:cNvPicPr>
+            <a:picLocks noChangeAspect="1"/>
+          </p:cNvPicPr>
+          <p:nvPr/>
+        </p:nvPicPr>
+        <p:blipFill>
+          <a:blip r:embed="rId2"/>
+          <a:stretch>
+            <a:fillRect/>
+          </a:stretch>
+        </p:blipFill>
+        <p:spPr>
+          <a:xfrm>
+            <a:off x="10561320" y="411480"/>
+            <a:ext cx="1206201" cy="320040"/>
+          </a:xfrm>
+          <a:prstGeom prst="rect">
+            <a:avLst/>
+          </a:prstGeom>
+        </p:spPr>
+      </p:pic>
+      <p:sp>
+        <p:nvSpPr>
+          <p:cNvPr id="4" name="TextBox 3"/>
+          <p:cNvSpPr txBox="1"/>
+          <p:nvPr/>
+        </p:nvSpPr>
+        <p:spPr>
+          <a:xfrm>
+            <a:off x="548640" y="438912"/>
+            <a:ext cx="7772400" cy="274320"/>
+          </a:xfrm>
+          <a:prstGeom prst="rect">
+            <a:avLst/>
+          </a:prstGeom>
+          <a:noFill/>
+        </p:spPr>
+        <p:txBody>
+          <a:bodyPr wrap="square" anchor="t">
+            <a:spAutoFit/>
+          </a:bodyPr>
+          <a:lstStyle/>
+          <a:p>
+            <a:pPr algn="l"/>
+            <a:r>
+              <a:rPr sz="1200" b="0">
+                <a:solidFill>
+                  <a:srgbClr val="5A5470"/>
+                </a:solidFill>
+                <a:latin typeface="DIN Next LT W23"/>
+                <a:ea typeface="DIN Next LT W23"/>
+                <a:cs typeface="DIN Next LT W23"/>
+              </a:rPr>
+              <a:t>S04  ·  Classical ML</a:t>
+            </a:r>
+          </a:p>
+        </p:txBody>
+      </p:sp>
+      <p:sp>
+        <p:nvSpPr>
+          <p:cNvPr id="5" name="Rectangle 4"/>
+          <p:cNvSpPr/>
+          <p:nvPr/>
+        </p:nvSpPr>
+        <p:spPr>
+          <a:xfrm>
+            <a:off x="548640" y="822960"/>
+            <a:ext cx="11064240" cy="10972"/>
+          </a:xfrm>
+          <a:prstGeom prst="rect">
+            <a:avLst/>
+          </a:prstGeom>
+          <a:solidFill>
+            <a:srgbClr val="E4DCF4"/>
+          </a:solidFill>
+          <a:ln>
+            <a:noFill/>
+          </a:ln>
+          <a:effectLst/>
+        </p:spPr>
+        <p:style>
+          <a:lnRef idx="1">
+            <a:schemeClr val="accent1"/>
+          </a:lnRef>
+          <a:fillRef idx="3">
+            <a:schemeClr val="accent1"/>
+          </a:fillRef>
+          <a:effectRef idx="2">
+            <a:schemeClr val="accent1"/>
+          </a:effectRef>
+          <a:fontRef idx="minor">
+            <a:schemeClr val="lt1"/>
+          </a:fontRef>
+        </p:style>
+        <p:txBody>
+          <a:bodyPr rtlCol="0" anchor="ctr"/>
+          <a:lstStyle/>
+          <a:p>
+            <a:pPr algn="ctr"/>
+          </a:p>
+        </p:txBody>
+      </p:sp>
+      <p:sp>
+        <p:nvSpPr>
+          <p:cNvPr id="6" name="TextBox 5"/>
+          <p:cNvSpPr txBox="1"/>
+          <p:nvPr/>
+        </p:nvSpPr>
+        <p:spPr>
+          <a:xfrm>
+            <a:off x="548640" y="1051560"/>
+            <a:ext cx="10241280" cy="594360"/>
+          </a:xfrm>
+          <a:prstGeom prst="rect">
+            <a:avLst/>
+          </a:prstGeom>
+          <a:noFill/>
+        </p:spPr>
+        <p:txBody>
+          <a:bodyPr wrap="square" anchor="t">
+            <a:spAutoFit/>
+          </a:bodyPr>
+          <a:lstStyle/>
+          <a:p>
+            <a:pPr algn="l"/>
+            <a:r>
+              <a:rPr sz="3200" b="1">
+                <a:solidFill>
+                  <a:srgbClr val="5234B7"/>
+                </a:solidFill>
+                <a:latin typeface="DIN Next LT W23"/>
+                <a:ea typeface="DIN Next LT W23"/>
+                <a:cs typeface="DIN Next LT W23"/>
+              </a:rPr>
+              <a:t>Precision, Recall, and F1-Score</a:t>
+            </a:r>
+          </a:p>
+        </p:txBody>
+      </p:sp>
+      <p:sp>
+        <p:nvSpPr>
+          <p:cNvPr id="7" name="TextBox 6"/>
+          <p:cNvSpPr txBox="1"/>
+          <p:nvPr/>
+        </p:nvSpPr>
+        <p:spPr>
+          <a:xfrm>
+            <a:off x="548640" y="1600200"/>
+            <a:ext cx="10241280" cy="365760"/>
+          </a:xfrm>
+          <a:prstGeom prst="rect">
+            <a:avLst/>
+          </a:prstGeom>
+          <a:noFill/>
+        </p:spPr>
+        <p:txBody>
+          <a:bodyPr wrap="square" anchor="t">
+            <a:spAutoFit/>
+          </a:bodyPr>
+          <a:lstStyle/>
+          <a:p>
+            <a:pPr algn="l"/>
+            <a:r>
+              <a:rPr sz="1500" b="0">
+                <a:solidFill>
+                  <a:srgbClr val="5A5470"/>
+                </a:solidFill>
+                <a:latin typeface="DIN Next LT W23"/>
+                <a:ea typeface="DIN Next LT W23"/>
+                <a:cs typeface="DIN Next LT W23"/>
+              </a:rPr>
+              <a:t>Beyond Accuracy</a:t>
+            </a:r>
+          </a:p>
+        </p:txBody>
+      </p:sp>
+      <p:sp>
+        <p:nvSpPr>
+          <p:cNvPr id="8" name="TextBox 7"/>
+          <p:cNvSpPr txBox="1"/>
+          <p:nvPr/>
+        </p:nvSpPr>
+        <p:spPr>
+          <a:xfrm>
+            <a:off x="548640" y="1920240"/>
+            <a:ext cx="10972800" cy="320040"/>
+          </a:xfrm>
+          <a:prstGeom prst="rect">
+            <a:avLst/>
+          </a:prstGeom>
+          <a:noFill/>
+        </p:spPr>
+        <p:txBody>
+          <a:bodyPr wrap="square" anchor="t">
+            <a:spAutoFit/>
+          </a:bodyPr>
+          <a:lstStyle/>
+          <a:p>
+            <a:pPr algn="l"/>
+            <a:r>
+              <a:rPr sz="1300" b="0">
+                <a:solidFill>
+                  <a:srgbClr val="5A5470"/>
+                </a:solidFill>
+                <a:latin typeface="DIN Next LT W23"/>
+                <a:ea typeface="DIN Next LT W23"/>
+                <a:cs typeface="DIN Next LT W23"/>
+              </a:rPr>
+              <a:t>Precision and recall trade off · F1 balances both when classes are imbalanced.</a:t>
+            </a:r>
+          </a:p>
+        </p:txBody>
+      </p:sp>
+      <p:sp>
+        <p:nvSpPr>
+          <p:cNvPr id="9" name="Rounded Rectangle 8"/>
+          <p:cNvSpPr/>
+          <p:nvPr/>
+        </p:nvSpPr>
+        <p:spPr>
+          <a:xfrm>
+            <a:off x="548640" y="2240280"/>
+            <a:ext cx="10972800" cy="3977639"/>
+          </a:xfrm>
+          <a:prstGeom prst="roundRect">
+            <a:avLst>
+              <a:gd name="adj" fmla="val 10000"/>
+            </a:avLst>
+          </a:prstGeom>
+          <a:solidFill>
+            <a:srgbClr val="EEE8FA"/>
+          </a:solidFill>
+          <a:ln>
+            <a:noFill/>
+          </a:ln>
+          <a:effectLst/>
+        </p:spPr>
+        <p:style>
+          <a:lnRef idx="1">
+            <a:schemeClr val="accent1"/>
+          </a:lnRef>
+          <a:fillRef idx="3">
+            <a:schemeClr val="accent1"/>
+          </a:fillRef>
+          <a:effectRef idx="2">
+            <a:schemeClr val="accent1"/>
+          </a:effectRef>
+          <a:fontRef idx="minor">
+            <a:schemeClr val="lt1"/>
+          </a:fontRef>
+        </p:style>
+        <p:txBody>
+          <a:bodyPr rtlCol="0" anchor="ctr"/>
+          <a:lstStyle/>
+          <a:p>
+            <a:pPr algn="ctr"/>
+          </a:p>
+        </p:txBody>
+      </p:sp>
+      <p:pic>
+        <p:nvPicPr>
+          <p:cNvPr id="10" name="Picture 9" descr="precision-recall-f1.png"/>
+          <p:cNvPicPr>
+            <a:picLocks noChangeAspect="1"/>
+          </p:cNvPicPr>
+          <p:nvPr/>
+        </p:nvPicPr>
+        <p:blipFill>
+          <a:blip r:embed="rId3"/>
+          <a:stretch>
+            <a:fillRect/>
+          </a:stretch>
+        </p:blipFill>
+        <p:spPr>
+          <a:xfrm>
+            <a:off x="2408970" y="2377440"/>
+            <a:ext cx="7252139" cy="3703320"/>
+          </a:xfrm>
+          <a:prstGeom prst="rect">
+            <a:avLst/>
+          </a:prstGeom>
+        </p:spPr>
+      </p:pic>
+      <p:sp>
+        <p:nvSpPr>
+          <p:cNvPr id="11" name="TextBox 10"/>
+          <p:cNvSpPr txBox="1"/>
+          <p:nvPr/>
+        </p:nvSpPr>
+        <p:spPr>
+          <a:xfrm>
+            <a:off x="548640" y="6309360"/>
+            <a:ext cx="10972800" cy="228600"/>
+          </a:xfrm>
+          <a:prstGeom prst="rect">
+            <a:avLst/>
+          </a:prstGeom>
+          <a:noFill/>
+        </p:spPr>
+        <p:txBody>
+          <a:bodyPr wrap="square" anchor="t">
+            <a:spAutoFit/>
+          </a:bodyPr>
+          <a:lstStyle/>
+          <a:p>
+            <a:pPr algn="l"/>
+            <a:r>
+              <a:rPr sz="1100" b="0">
+                <a:solidFill>
+                  <a:srgbClr val="5A5470"/>
+                </a:solidFill>
+                <a:latin typeface="DIN Next LT W23"/>
+                <a:ea typeface="DIN Next LT W23"/>
+                <a:cs typeface="DIN Next LT W23"/>
+              </a:rPr>
+              <a:t>Use F1 especially when class distribution is imbalanced.</a:t>
+            </a:r>
+          </a:p>
+        </p:txBody>
+      </p:sp>
+      <p:sp>
+        <p:nvSpPr>
+          <p:cNvPr id="12" name="Rectangle 11"/>
+          <p:cNvSpPr/>
+          <p:nvPr/>
+        </p:nvSpPr>
+        <p:spPr>
+          <a:xfrm>
+            <a:off x="548640" y="6446520"/>
+            <a:ext cx="11064240" cy="10972"/>
+          </a:xfrm>
+          <a:prstGeom prst="rect">
+            <a:avLst/>
+          </a:prstGeom>
+          <a:solidFill>
+            <a:srgbClr val="5234B7"/>
+          </a:solidFill>
+          <a:ln>
+            <a:noFill/>
+          </a:ln>
+          <a:effectLst/>
+        </p:spPr>
+        <p:style>
+          <a:lnRef idx="1">
+            <a:schemeClr val="accent1"/>
+          </a:lnRef>
+          <a:fillRef idx="3">
+            <a:schemeClr val="accent1"/>
+          </a:fillRef>
+          <a:effectRef idx="2">
+            <a:schemeClr val="accent1"/>
+          </a:effectRef>
+          <a:fontRef idx="minor">
+            <a:schemeClr val="lt1"/>
+          </a:fontRef>
+        </p:style>
+        <p:txBody>
+          <a:bodyPr rtlCol="0" anchor="ctr"/>
+          <a:lstStyle/>
+          <a:p>
+            <a:pPr algn="ctr"/>
+          </a:p>
+        </p:txBody>
+      </p:sp>
+      <p:sp>
+        <p:nvSpPr>
+          <p:cNvPr id="13" name="TextBox 12"/>
+          <p:cNvSpPr txBox="1"/>
+          <p:nvPr/>
+        </p:nvSpPr>
+        <p:spPr>
+          <a:xfrm>
+            <a:off x="548640" y="6510528"/>
+            <a:ext cx="2743200" cy="256032"/>
+          </a:xfrm>
+          <a:prstGeom prst="rect">
+            <a:avLst/>
+          </a:prstGeom>
+          <a:noFill/>
+        </p:spPr>
+        <p:txBody>
+          <a:bodyPr wrap="square" anchor="t">
+            <a:spAutoFit/>
+          </a:bodyPr>
+          <a:lstStyle/>
+          <a:p>
+            <a:pPr algn="l"/>
+            <a:r>
+              <a:rPr sz="1100" b="1">
+                <a:solidFill>
+                  <a:srgbClr val="5234B7"/>
+                </a:solidFill>
+                <a:latin typeface="DIN Next LT W23"/>
+                <a:ea typeface="DIN Next LT W23"/>
+                <a:cs typeface="DIN Next LT W23"/>
+              </a:rPr>
+              <a:t>ETRA</a:t>
+            </a:r>
+          </a:p>
+        </p:txBody>
+      </p:sp>
+      <p:sp>
+        <p:nvSpPr>
+          <p:cNvPr id="14" name="TextBox 13"/>
+          <p:cNvSpPr txBox="1"/>
+          <p:nvPr/>
+        </p:nvSpPr>
+        <p:spPr>
+          <a:xfrm>
+            <a:off x="9601200" y="6510528"/>
+            <a:ext cx="2011680" cy="256032"/>
+          </a:xfrm>
+          <a:prstGeom prst="rect">
+            <a:avLst/>
+          </a:prstGeom>
+          <a:noFill/>
+        </p:spPr>
+        <p:txBody>
+          <a:bodyPr wrap="square" anchor="t">
+            <a:spAutoFit/>
+          </a:bodyPr>
+          <a:lstStyle/>
+          <a:p>
+            <a:pPr algn="r"/>
+            <a:r>
+              <a:rPr sz="1100" b="0">
+                <a:solidFill>
+                  <a:srgbClr val="5A5470"/>
+                </a:solidFill>
+                <a:latin typeface="DIN Next LT W23"/>
+                <a:ea typeface="DIN Next LT W23"/>
+                <a:cs typeface="DIN Next LT W23"/>
+              </a:rPr>
+              <a:t>18  /  18</a:t>
             </a:r>
           </a:p>
         </p:txBody>
@@ -10727,7 +11956,7 @@
                 <a:ea typeface="DIN Next LT W23"/>
                 <a:cs typeface="DIN Next LT W23"/>
               </a:rPr>
-              <a:t>02  /  16</a:t>
+              <a:t>02  /  18</a:t>
             </a:r>
           </a:p>
         </p:txBody>
@@ -11434,7 +12663,7 @@
                 <a:ea typeface="DIN Next LT W23"/>
                 <a:cs typeface="DIN Next LT W23"/>
               </a:rPr>
-              <a:t>03  /  16</a:t>
+              <a:t>03  /  18</a:t>
             </a:r>
           </a:p>
         </p:txBody>
@@ -12097,7 +13326,7 @@
                 <a:ea typeface="DIN Next LT W23"/>
                 <a:cs typeface="DIN Next LT W23"/>
               </a:rPr>
-              <a:t>04  /  16</a:t>
+              <a:t>04  /  18</a:t>
             </a:r>
           </a:p>
         </p:txBody>
@@ -12913,7 +14142,7 @@
                 <a:ea typeface="DIN Next LT W23"/>
                 <a:cs typeface="DIN Next LT W23"/>
               </a:rPr>
-              <a:t>05  /  16</a:t>
+              <a:t>05  /  18</a:t>
             </a:r>
           </a:p>
         </p:txBody>
@@ -13424,7 +14653,7 @@
                 <a:ea typeface="DIN Next LT W23"/>
                 <a:cs typeface="DIN Next LT W23"/>
               </a:rPr>
-              <a:t>06  /  16</a:t>
+              <a:t>06  /  18</a:t>
             </a:r>
           </a:p>
         </p:txBody>
@@ -14203,7 +15432,7 @@
                 <a:ea typeface="DIN Next LT W23"/>
                 <a:cs typeface="DIN Next LT W23"/>
               </a:rPr>
-              <a:t>07  /  16</a:t>
+              <a:t>07  /  18</a:t>
             </a:r>
           </a:p>
         </p:txBody>
@@ -14964,7 +16193,7 @@
                 <a:ea typeface="DIN Next LT W23"/>
                 <a:cs typeface="DIN Next LT W23"/>
               </a:rPr>
-              <a:t>08  /  16</a:t>
+              <a:t>08  /  18</a:t>
             </a:r>
           </a:p>
         </p:txBody>
@@ -15743,7 +16972,7 @@
                 <a:ea typeface="DIN Next LT W23"/>
                 <a:cs typeface="DIN Next LT W23"/>
               </a:rPr>
-              <a:t>09  /  16</a:t>
+              <a:t>09  /  18</a:t>
             </a:r>
           </a:p>
         </p:txBody>

</xml_diff>